<commit_message>
wip: add HCL channel
</commit_message>
<xml_diff>
--- a/doc/Labels.pptx
+++ b/doc/Labels.pptx
@@ -262,7 +262,7 @@
           <a:p>
             <a:fld id="{C6985964-12C0-46FB-9AC3-21523FFAE508}" type="datetimeFigureOut">
               <a:rPr lang="de-DE" smtClean="0"/>
-              <a:t>20.10.2024</a:t>
+              <a:t>10.05.2025</a:t>
             </a:fld>
             <a:endParaRPr lang="de-DE"/>
           </a:p>
@@ -460,7 +460,7 @@
           <a:p>
             <a:fld id="{C6985964-12C0-46FB-9AC3-21523FFAE508}" type="datetimeFigureOut">
               <a:rPr lang="de-DE" smtClean="0"/>
-              <a:t>20.10.2024</a:t>
+              <a:t>10.05.2025</a:t>
             </a:fld>
             <a:endParaRPr lang="de-DE"/>
           </a:p>
@@ -668,7 +668,7 @@
           <a:p>
             <a:fld id="{C6985964-12C0-46FB-9AC3-21523FFAE508}" type="datetimeFigureOut">
               <a:rPr lang="de-DE" smtClean="0"/>
-              <a:t>20.10.2024</a:t>
+              <a:t>10.05.2025</a:t>
             </a:fld>
             <a:endParaRPr lang="de-DE"/>
           </a:p>
@@ -866,7 +866,7 @@
           <a:p>
             <a:fld id="{C6985964-12C0-46FB-9AC3-21523FFAE508}" type="datetimeFigureOut">
               <a:rPr lang="de-DE" smtClean="0"/>
-              <a:t>20.10.2024</a:t>
+              <a:t>10.05.2025</a:t>
             </a:fld>
             <a:endParaRPr lang="de-DE"/>
           </a:p>
@@ -1141,7 +1141,7 @@
           <a:p>
             <a:fld id="{C6985964-12C0-46FB-9AC3-21523FFAE508}" type="datetimeFigureOut">
               <a:rPr lang="de-DE" smtClean="0"/>
-              <a:t>20.10.2024</a:t>
+              <a:t>10.05.2025</a:t>
             </a:fld>
             <a:endParaRPr lang="de-DE"/>
           </a:p>
@@ -1406,7 +1406,7 @@
           <a:p>
             <a:fld id="{C6985964-12C0-46FB-9AC3-21523FFAE508}" type="datetimeFigureOut">
               <a:rPr lang="de-DE" smtClean="0"/>
-              <a:t>20.10.2024</a:t>
+              <a:t>10.05.2025</a:t>
             </a:fld>
             <a:endParaRPr lang="de-DE"/>
           </a:p>
@@ -1818,7 +1818,7 @@
           <a:p>
             <a:fld id="{C6985964-12C0-46FB-9AC3-21523FFAE508}" type="datetimeFigureOut">
               <a:rPr lang="de-DE" smtClean="0"/>
-              <a:t>20.10.2024</a:t>
+              <a:t>10.05.2025</a:t>
             </a:fld>
             <a:endParaRPr lang="de-DE"/>
           </a:p>
@@ -1959,7 +1959,7 @@
           <a:p>
             <a:fld id="{C6985964-12C0-46FB-9AC3-21523FFAE508}" type="datetimeFigureOut">
               <a:rPr lang="de-DE" smtClean="0"/>
-              <a:t>20.10.2024</a:t>
+              <a:t>10.05.2025</a:t>
             </a:fld>
             <a:endParaRPr lang="de-DE"/>
           </a:p>
@@ -2072,7 +2072,7 @@
           <a:p>
             <a:fld id="{C6985964-12C0-46FB-9AC3-21523FFAE508}" type="datetimeFigureOut">
               <a:rPr lang="de-DE" smtClean="0"/>
-              <a:t>20.10.2024</a:t>
+              <a:t>10.05.2025</a:t>
             </a:fld>
             <a:endParaRPr lang="de-DE"/>
           </a:p>
@@ -2383,7 +2383,7 @@
           <a:p>
             <a:fld id="{C6985964-12C0-46FB-9AC3-21523FFAE508}" type="datetimeFigureOut">
               <a:rPr lang="de-DE" smtClean="0"/>
-              <a:t>20.10.2024</a:t>
+              <a:t>10.05.2025</a:t>
             </a:fld>
             <a:endParaRPr lang="de-DE"/>
           </a:p>
@@ -2671,7 +2671,7 @@
           <a:p>
             <a:fld id="{C6985964-12C0-46FB-9AC3-21523FFAE508}" type="datetimeFigureOut">
               <a:rPr lang="de-DE" smtClean="0"/>
-              <a:t>20.10.2024</a:t>
+              <a:t>10.05.2025</a:t>
             </a:fld>
             <a:endParaRPr lang="de-DE"/>
           </a:p>
@@ -2912,7 +2912,7 @@
           <a:p>
             <a:fld id="{C6985964-12C0-46FB-9AC3-21523FFAE508}" type="datetimeFigureOut">
               <a:rPr lang="de-DE" smtClean="0"/>
-              <a:t>20.10.2024</a:t>
+              <a:t>10.05.2025</a:t>
             </a:fld>
             <a:endParaRPr lang="de-DE"/>
           </a:p>
@@ -47950,6 +47950,227 @@
       </p:grpSpPr>
       <p:graphicFrame>
         <p:nvGraphicFramePr>
+          <p:cNvPr id="17" name="Tabelle 16">
+            <a:extLst>
+              <a:ext uri="{FF2B5EF4-FFF2-40B4-BE49-F238E27FC236}">
+                <a16:creationId xmlns:a16="http://schemas.microsoft.com/office/drawing/2014/main" id="{314DFFCF-035A-4110-9C16-71BD02B80E0E}"/>
+              </a:ext>
+            </a:extLst>
+          </p:cNvPr>
+          <p:cNvGraphicFramePr>
+            <a:graphicFrameLocks noGrp="1"/>
+          </p:cNvGraphicFramePr>
+          <p:nvPr>
+            <p:extLst>
+              <p:ext uri="{D42A27DB-BD31-4B8C-83A1-F6EECF244321}">
+                <p14:modId xmlns:p14="http://schemas.microsoft.com/office/powerpoint/2010/main" val="1807311361"/>
+              </p:ext>
+            </p:extLst>
+          </p:nvPr>
+        </p:nvGraphicFramePr>
+        <p:xfrm>
+          <a:off x="544931" y="3696443"/>
+          <a:ext cx="3159940" cy="182880"/>
+        </p:xfrm>
+        <a:graphic>
+          <a:graphicData uri="http://schemas.openxmlformats.org/drawingml/2006/table">
+            <a:tbl>
+              <a:tblPr bandRow="1">
+                <a:effectLst/>
+                <a:tableStyleId>{5C22544A-7EE6-4342-B048-85BDC9FD1C3A}</a:tableStyleId>
+              </a:tblPr>
+              <a:tblGrid>
+                <a:gridCol w="451420">
+                  <a:extLst>
+                    <a:ext uri="{9D8B030D-6E8A-4147-A177-3AD203B41FA5}">
+                      <a16:colId xmlns:a16="http://schemas.microsoft.com/office/drawing/2014/main" val="3213005197"/>
+                    </a:ext>
+                  </a:extLst>
+                </a:gridCol>
+                <a:gridCol w="451420">
+                  <a:extLst>
+                    <a:ext uri="{9D8B030D-6E8A-4147-A177-3AD203B41FA5}">
+                      <a16:colId xmlns:a16="http://schemas.microsoft.com/office/drawing/2014/main" val="2273598585"/>
+                    </a:ext>
+                  </a:extLst>
+                </a:gridCol>
+                <a:gridCol w="451420">
+                  <a:extLst>
+                    <a:ext uri="{9D8B030D-6E8A-4147-A177-3AD203B41FA5}">
+                      <a16:colId xmlns:a16="http://schemas.microsoft.com/office/drawing/2014/main" val="3896253277"/>
+                    </a:ext>
+                  </a:extLst>
+                </a:gridCol>
+                <a:gridCol w="451420">
+                  <a:extLst>
+                    <a:ext uri="{9D8B030D-6E8A-4147-A177-3AD203B41FA5}">
+                      <a16:colId xmlns:a16="http://schemas.microsoft.com/office/drawing/2014/main" val="3813640509"/>
+                    </a:ext>
+                  </a:extLst>
+                </a:gridCol>
+                <a:gridCol w="451420">
+                  <a:extLst>
+                    <a:ext uri="{9D8B030D-6E8A-4147-A177-3AD203B41FA5}">
+                      <a16:colId xmlns:a16="http://schemas.microsoft.com/office/drawing/2014/main" val="1176278402"/>
+                    </a:ext>
+                  </a:extLst>
+                </a:gridCol>
+                <a:gridCol w="451420">
+                  <a:extLst>
+                    <a:ext uri="{9D8B030D-6E8A-4147-A177-3AD203B41FA5}">
+                      <a16:colId xmlns:a16="http://schemas.microsoft.com/office/drawing/2014/main" val="4111233001"/>
+                    </a:ext>
+                  </a:extLst>
+                </a:gridCol>
+                <a:gridCol w="451420">
+                  <a:extLst>
+                    <a:ext uri="{9D8B030D-6E8A-4147-A177-3AD203B41FA5}">
+                      <a16:colId xmlns:a16="http://schemas.microsoft.com/office/drawing/2014/main" val="1749566262"/>
+                    </a:ext>
+                  </a:extLst>
+                </a:gridCol>
+              </a:tblGrid>
+              <a:tr h="128134">
+                <a:tc>
+                  <a:txBody>
+                    <a:bodyPr/>
+                    <a:lstStyle/>
+                    <a:p>
+                      <a:pPr algn="l"/>
+                      <a:r>
+                        <a:rPr lang="de-DE" sz="1200" b="1" dirty="0">
+                          <a:solidFill>
+                            <a:schemeClr val="tx1"/>
+                          </a:solidFill>
+                        </a:rPr>
+                        <a:t>  0</a:t>
+                      </a:r>
+                    </a:p>
+                  </a:txBody>
+                  <a:tcPr marL="0" marR="0" marT="0" marB="0" anchor="ctr">
+                    <a:noFill/>
+                  </a:tcPr>
+                </a:tc>
+                <a:tc>
+                  <a:txBody>
+                    <a:bodyPr/>
+                    <a:lstStyle/>
+                    <a:p>
+                      <a:pPr algn="l"/>
+                      <a:endParaRPr lang="de-DE" sz="1200" b="1" dirty="0">
+                        <a:solidFill>
+                          <a:schemeClr val="tx1"/>
+                        </a:solidFill>
+                      </a:endParaRPr>
+                    </a:p>
+                  </a:txBody>
+                  <a:tcPr marL="0" marR="0" marT="0" marB="0" anchor="ctr">
+                    <a:noFill/>
+                  </a:tcPr>
+                </a:tc>
+                <a:tc>
+                  <a:txBody>
+                    <a:bodyPr/>
+                    <a:lstStyle/>
+                    <a:p>
+                      <a:pPr algn="ctr"/>
+                      <a:endParaRPr lang="de-DE" sz="1200" b="1" dirty="0">
+                        <a:solidFill>
+                          <a:schemeClr val="tx1"/>
+                        </a:solidFill>
+                      </a:endParaRPr>
+                    </a:p>
+                  </a:txBody>
+                  <a:tcPr marL="0" marR="0" marT="0" marB="0" anchor="ctr">
+                    <a:noFill/>
+                  </a:tcPr>
+                </a:tc>
+                <a:tc>
+                  <a:txBody>
+                    <a:bodyPr/>
+                    <a:lstStyle/>
+                    <a:p>
+                      <a:pPr algn="ctr"/>
+                      <a:r>
+                        <a:rPr lang="de-DE" sz="1200" b="1" dirty="0">
+                          <a:solidFill>
+                            <a:schemeClr val="tx1"/>
+                          </a:solidFill>
+                        </a:rPr>
+                        <a:t>12</a:t>
+                      </a:r>
+                    </a:p>
+                  </a:txBody>
+                  <a:tcPr marL="0" marR="0" marT="0" marB="0" anchor="ctr">
+                    <a:noFill/>
+                  </a:tcPr>
+                </a:tc>
+                <a:tc>
+                  <a:txBody>
+                    <a:bodyPr/>
+                    <a:lstStyle/>
+                    <a:p>
+                      <a:pPr algn="ctr"/>
+                      <a:endParaRPr lang="de-DE" sz="1200" b="1" dirty="0">
+                        <a:solidFill>
+                          <a:schemeClr val="tx1"/>
+                        </a:solidFill>
+                      </a:endParaRPr>
+                    </a:p>
+                  </a:txBody>
+                  <a:tcPr marL="0" marR="0" marT="0" marB="0" anchor="ctr">
+                    <a:noFill/>
+                  </a:tcPr>
+                </a:tc>
+                <a:tc>
+                  <a:txBody>
+                    <a:bodyPr/>
+                    <a:lstStyle/>
+                    <a:p>
+                      <a:pPr algn="ctr"/>
+                      <a:endParaRPr lang="de-DE" sz="1200" b="1" dirty="0">
+                        <a:solidFill>
+                          <a:schemeClr val="tx1"/>
+                        </a:solidFill>
+                      </a:endParaRPr>
+                    </a:p>
+                  </a:txBody>
+                  <a:tcPr marL="0" marR="0" marT="0" marB="0" anchor="ctr">
+                    <a:noFill/>
+                  </a:tcPr>
+                </a:tc>
+                <a:tc>
+                  <a:txBody>
+                    <a:bodyPr/>
+                    <a:lstStyle/>
+                    <a:p>
+                      <a:pPr algn="l"/>
+                      <a:r>
+                        <a:rPr lang="de-DE" sz="1200" b="1" dirty="0">
+                          <a:solidFill>
+                            <a:schemeClr val="tx1"/>
+                          </a:solidFill>
+                        </a:rPr>
+                        <a:t>       24</a:t>
+                      </a:r>
+                    </a:p>
+                  </a:txBody>
+                  <a:tcPr marL="0" marR="0" marT="0" marB="0" anchor="ctr">
+                    <a:noFill/>
+                  </a:tcPr>
+                </a:tc>
+                <a:extLst>
+                  <a:ext uri="{0D108BD9-81ED-4DB2-BD59-A6C34878D82A}">
+                    <a16:rowId xmlns:a16="http://schemas.microsoft.com/office/drawing/2014/main" val="4166272810"/>
+                  </a:ext>
+                </a:extLst>
+              </a:tr>
+            </a:tbl>
+          </a:graphicData>
+        </a:graphic>
+      </p:graphicFrame>
+      <p:graphicFrame>
+        <p:nvGraphicFramePr>
           <p:cNvPr id="4" name="Tabelle 3">
             <a:extLst>
               <a:ext uri="{FF2B5EF4-FFF2-40B4-BE49-F238E27FC236}">
@@ -48814,6 +49035,952 @@
           </a:fontRef>
         </p:style>
       </p:cxnSp>
+      <p:sp>
+        <p:nvSpPr>
+          <p:cNvPr id="2" name="Textfeld 1">
+            <a:extLst>
+              <a:ext uri="{FF2B5EF4-FFF2-40B4-BE49-F238E27FC236}">
+                <a16:creationId xmlns:a16="http://schemas.microsoft.com/office/drawing/2014/main" id="{6D78B382-7995-465F-81BE-D0E15ACDCF08}"/>
+              </a:ext>
+            </a:extLst>
+          </p:cNvPr>
+          <p:cNvSpPr txBox="1"/>
+          <p:nvPr/>
+        </p:nvSpPr>
+        <p:spPr>
+          <a:xfrm>
+            <a:off x="544948" y="2286913"/>
+            <a:ext cx="3159948" cy="1359673"/>
+          </a:xfrm>
+          <a:prstGeom prst="rect">
+            <a:avLst/>
+          </a:prstGeom>
+          <a:gradFill flip="none" rotWithShape="1">
+            <a:gsLst>
+              <a:gs pos="15000">
+                <a:srgbClr val="FF9933"/>
+              </a:gs>
+              <a:gs pos="0">
+                <a:srgbClr val="FF9933"/>
+              </a:gs>
+              <a:gs pos="42000">
+                <a:srgbClr val="F2A16A"/>
+              </a:gs>
+              <a:gs pos="100000">
+                <a:schemeClr val="accent1">
+                  <a:lumMod val="30000"/>
+                  <a:lumOff val="70000"/>
+                </a:schemeClr>
+              </a:gs>
+            </a:gsLst>
+            <a:lin ang="16200000" scaled="1"/>
+            <a:tileRect/>
+          </a:gradFill>
+          <a:ln>
+            <a:noFill/>
+          </a:ln>
+        </p:spPr>
+        <p:txBody>
+          <a:bodyPr wrap="square" rtlCol="0">
+            <a:spAutoFit/>
+          </a:bodyPr>
+          <a:lstStyle/>
+          <a:p>
+            <a:endParaRPr lang="de-DE" dirty="0"/>
+          </a:p>
+        </p:txBody>
+      </p:sp>
+      <p:cxnSp>
+        <p:nvCxnSpPr>
+          <p:cNvPr id="10" name="Gerader Verbinder 9">
+            <a:extLst>
+              <a:ext uri="{FF2B5EF4-FFF2-40B4-BE49-F238E27FC236}">
+                <a16:creationId xmlns:a16="http://schemas.microsoft.com/office/drawing/2014/main" id="{A9E74356-5711-41FC-B3FE-1301ABAA58C7}"/>
+              </a:ext>
+            </a:extLst>
+          </p:cNvPr>
+          <p:cNvCxnSpPr/>
+          <p:nvPr/>
+        </p:nvCxnSpPr>
+        <p:spPr>
+          <a:xfrm>
+            <a:off x="544948" y="3646586"/>
+            <a:ext cx="3159948" cy="0"/>
+          </a:xfrm>
+          <a:prstGeom prst="line">
+            <a:avLst/>
+          </a:prstGeom>
+          <a:ln>
+            <a:solidFill>
+              <a:schemeClr val="tx1"/>
+            </a:solidFill>
+          </a:ln>
+        </p:spPr>
+        <p:style>
+          <a:lnRef idx="1">
+            <a:schemeClr val="accent1"/>
+          </a:lnRef>
+          <a:fillRef idx="0">
+            <a:schemeClr val="accent1"/>
+          </a:fillRef>
+          <a:effectRef idx="0">
+            <a:schemeClr val="accent1"/>
+          </a:effectRef>
+          <a:fontRef idx="minor">
+            <a:schemeClr val="tx1"/>
+          </a:fontRef>
+        </p:style>
+      </p:cxnSp>
+      <p:cxnSp>
+        <p:nvCxnSpPr>
+          <p:cNvPr id="12" name="Gerader Verbinder 11">
+            <a:extLst>
+              <a:ext uri="{FF2B5EF4-FFF2-40B4-BE49-F238E27FC236}">
+                <a16:creationId xmlns:a16="http://schemas.microsoft.com/office/drawing/2014/main" id="{C22924E7-7126-4DC1-AB0A-9FCC942120CC}"/>
+              </a:ext>
+            </a:extLst>
+          </p:cNvPr>
+          <p:cNvCxnSpPr/>
+          <p:nvPr/>
+        </p:nvCxnSpPr>
+        <p:spPr>
+          <a:xfrm>
+            <a:off x="544948" y="2286913"/>
+            <a:ext cx="0" cy="1494512"/>
+          </a:xfrm>
+          <a:prstGeom prst="line">
+            <a:avLst/>
+          </a:prstGeom>
+          <a:ln>
+            <a:solidFill>
+              <a:schemeClr val="tx1"/>
+            </a:solidFill>
+          </a:ln>
+        </p:spPr>
+        <p:style>
+          <a:lnRef idx="1">
+            <a:schemeClr val="accent1"/>
+          </a:lnRef>
+          <a:fillRef idx="0">
+            <a:schemeClr val="accent1"/>
+          </a:fillRef>
+          <a:effectRef idx="0">
+            <a:schemeClr val="accent1"/>
+          </a:effectRef>
+          <a:fontRef idx="minor">
+            <a:schemeClr val="tx1"/>
+          </a:fontRef>
+        </p:style>
+      </p:cxnSp>
+      <p:cxnSp>
+        <p:nvCxnSpPr>
+          <p:cNvPr id="14" name="Gerader Verbinder 13">
+            <a:extLst>
+              <a:ext uri="{FF2B5EF4-FFF2-40B4-BE49-F238E27FC236}">
+                <a16:creationId xmlns:a16="http://schemas.microsoft.com/office/drawing/2014/main" id="{B39698F1-D46C-414D-BF1C-BE180A404E26}"/>
+              </a:ext>
+            </a:extLst>
+          </p:cNvPr>
+          <p:cNvCxnSpPr>
+            <a:cxnSpLocks/>
+            <a:endCxn id="17" idx="0"/>
+          </p:cNvCxnSpPr>
+          <p:nvPr/>
+        </p:nvCxnSpPr>
+        <p:spPr>
+          <a:xfrm flipH="1">
+            <a:off x="2124901" y="3646585"/>
+            <a:ext cx="1200" cy="49858"/>
+          </a:xfrm>
+          <a:prstGeom prst="line">
+            <a:avLst/>
+          </a:prstGeom>
+          <a:ln>
+            <a:solidFill>
+              <a:schemeClr val="tx1"/>
+            </a:solidFill>
+          </a:ln>
+        </p:spPr>
+        <p:style>
+          <a:lnRef idx="1">
+            <a:schemeClr val="accent1"/>
+          </a:lnRef>
+          <a:fillRef idx="0">
+            <a:schemeClr val="accent1"/>
+          </a:fillRef>
+          <a:effectRef idx="0">
+            <a:schemeClr val="accent1"/>
+          </a:effectRef>
+          <a:fontRef idx="minor">
+            <a:schemeClr val="tx1"/>
+          </a:fontRef>
+        </p:style>
+      </p:cxnSp>
+      <p:cxnSp>
+        <p:nvCxnSpPr>
+          <p:cNvPr id="16" name="Gerader Verbinder 15">
+            <a:extLst>
+              <a:ext uri="{FF2B5EF4-FFF2-40B4-BE49-F238E27FC236}">
+                <a16:creationId xmlns:a16="http://schemas.microsoft.com/office/drawing/2014/main" id="{46932505-B707-4F9B-94BF-70AB7F1436BC}"/>
+              </a:ext>
+            </a:extLst>
+          </p:cNvPr>
+          <p:cNvCxnSpPr>
+            <a:cxnSpLocks/>
+          </p:cNvCxnSpPr>
+          <p:nvPr/>
+        </p:nvCxnSpPr>
+        <p:spPr>
+          <a:xfrm>
+            <a:off x="3704896" y="3646585"/>
+            <a:ext cx="0" cy="134839"/>
+          </a:xfrm>
+          <a:prstGeom prst="line">
+            <a:avLst/>
+          </a:prstGeom>
+          <a:ln>
+            <a:solidFill>
+              <a:schemeClr val="tx1"/>
+            </a:solidFill>
+          </a:ln>
+        </p:spPr>
+        <p:style>
+          <a:lnRef idx="1">
+            <a:schemeClr val="accent1"/>
+          </a:lnRef>
+          <a:fillRef idx="0">
+            <a:schemeClr val="accent1"/>
+          </a:fillRef>
+          <a:effectRef idx="0">
+            <a:schemeClr val="accent1"/>
+          </a:effectRef>
+          <a:fontRef idx="minor">
+            <a:schemeClr val="tx1"/>
+          </a:fontRef>
+        </p:style>
+      </p:cxnSp>
+      <p:pic>
+        <p:nvPicPr>
+          <p:cNvPr id="23" name="Grafik 22">
+            <a:extLst>
+              <a:ext uri="{FF2B5EF4-FFF2-40B4-BE49-F238E27FC236}">
+                <a16:creationId xmlns:a16="http://schemas.microsoft.com/office/drawing/2014/main" id="{CB7D55BB-418B-4751-AC62-6F7F865D9C13}"/>
+              </a:ext>
+            </a:extLst>
+          </p:cNvPr>
+          <p:cNvPicPr>
+            <a:picLocks noChangeAspect="1"/>
+          </p:cNvPicPr>
+          <p:nvPr/>
+        </p:nvPicPr>
+        <p:blipFill>
+          <a:blip r:embed="rId2">
+            <a:extLst>
+              <a:ext uri="{28A0092B-C50C-407E-A947-70E740481C1C}">
+                <a14:useLocalDpi xmlns:a14="http://schemas.microsoft.com/office/drawing/2010/main" val="0"/>
+              </a:ext>
+            </a:extLst>
+          </a:blip>
+          <a:stretch>
+            <a:fillRect/>
+          </a:stretch>
+        </p:blipFill>
+        <p:spPr>
+          <a:xfrm>
+            <a:off x="1182525" y="3696443"/>
+            <a:ext cx="304800" cy="304800"/>
+          </a:xfrm>
+          <a:prstGeom prst="rect">
+            <a:avLst/>
+          </a:prstGeom>
+        </p:spPr>
+      </p:pic>
+      <p:pic>
+        <p:nvPicPr>
+          <p:cNvPr id="25" name="Grafik 24">
+            <a:extLst>
+              <a:ext uri="{FF2B5EF4-FFF2-40B4-BE49-F238E27FC236}">
+                <a16:creationId xmlns:a16="http://schemas.microsoft.com/office/drawing/2014/main" id="{8925CCE7-B378-4C88-BE3F-DF4587D226E5}"/>
+              </a:ext>
+            </a:extLst>
+          </p:cNvPr>
+          <p:cNvPicPr>
+            <a:picLocks noChangeAspect="1"/>
+          </p:cNvPicPr>
+          <p:nvPr/>
+        </p:nvPicPr>
+        <p:blipFill>
+          <a:blip r:embed="rId3">
+            <a:extLst>
+              <a:ext uri="{28A0092B-C50C-407E-A947-70E740481C1C}">
+                <a14:useLocalDpi xmlns:a14="http://schemas.microsoft.com/office/drawing/2010/main" val="0"/>
+              </a:ext>
+            </a:extLst>
+          </a:blip>
+          <a:stretch>
+            <a:fillRect/>
+          </a:stretch>
+        </p:blipFill>
+        <p:spPr>
+          <a:xfrm>
+            <a:off x="2763085" y="3696443"/>
+            <a:ext cx="304800" cy="304800"/>
+          </a:xfrm>
+          <a:prstGeom prst="rect">
+            <a:avLst/>
+          </a:prstGeom>
+        </p:spPr>
+      </p:pic>
+      <p:cxnSp>
+        <p:nvCxnSpPr>
+          <p:cNvPr id="27" name="Gerader Verbinder 26">
+            <a:extLst>
+              <a:ext uri="{FF2B5EF4-FFF2-40B4-BE49-F238E27FC236}">
+                <a16:creationId xmlns:a16="http://schemas.microsoft.com/office/drawing/2014/main" id="{B84C8F3A-512E-48FF-8E64-A0DB6843889F}"/>
+              </a:ext>
+            </a:extLst>
+          </p:cNvPr>
+          <p:cNvCxnSpPr>
+            <a:cxnSpLocks/>
+          </p:cNvCxnSpPr>
+          <p:nvPr/>
+        </p:nvCxnSpPr>
+        <p:spPr>
+          <a:xfrm>
+            <a:off x="409575" y="3381375"/>
+            <a:ext cx="3295295" cy="0"/>
+          </a:xfrm>
+          <a:prstGeom prst="line">
+            <a:avLst/>
+          </a:prstGeom>
+          <a:ln w="9525">
+            <a:solidFill>
+              <a:schemeClr val="tx1"/>
+            </a:solidFill>
+            <a:prstDash val="dash"/>
+          </a:ln>
+        </p:spPr>
+        <p:style>
+          <a:lnRef idx="1">
+            <a:schemeClr val="accent1"/>
+          </a:lnRef>
+          <a:fillRef idx="0">
+            <a:schemeClr val="accent1"/>
+          </a:fillRef>
+          <a:effectRef idx="0">
+            <a:schemeClr val="accent1"/>
+          </a:effectRef>
+          <a:fontRef idx="minor">
+            <a:schemeClr val="tx1"/>
+          </a:fontRef>
+        </p:style>
+      </p:cxnSp>
+      <p:cxnSp>
+        <p:nvCxnSpPr>
+          <p:cNvPr id="30" name="Gerader Verbinder 29">
+            <a:extLst>
+              <a:ext uri="{FF2B5EF4-FFF2-40B4-BE49-F238E27FC236}">
+                <a16:creationId xmlns:a16="http://schemas.microsoft.com/office/drawing/2014/main" id="{E48310A9-EEAD-4E0B-AF0C-8534CD9651EE}"/>
+              </a:ext>
+            </a:extLst>
+          </p:cNvPr>
+          <p:cNvCxnSpPr>
+            <a:cxnSpLocks/>
+          </p:cNvCxnSpPr>
+          <p:nvPr/>
+        </p:nvCxnSpPr>
+        <p:spPr>
+          <a:xfrm>
+            <a:off x="409575" y="2528888"/>
+            <a:ext cx="3295295" cy="0"/>
+          </a:xfrm>
+          <a:prstGeom prst="line">
+            <a:avLst/>
+          </a:prstGeom>
+          <a:ln w="9525">
+            <a:solidFill>
+              <a:schemeClr val="tx1"/>
+            </a:solidFill>
+            <a:prstDash val="dash"/>
+          </a:ln>
+        </p:spPr>
+        <p:style>
+          <a:lnRef idx="1">
+            <a:schemeClr val="accent1"/>
+          </a:lnRef>
+          <a:fillRef idx="0">
+            <a:schemeClr val="accent1"/>
+          </a:fillRef>
+          <a:effectRef idx="0">
+            <a:schemeClr val="accent1"/>
+          </a:effectRef>
+          <a:fontRef idx="minor">
+            <a:schemeClr val="tx1"/>
+          </a:fontRef>
+        </p:style>
+      </p:cxnSp>
+      <p:sp>
+        <p:nvSpPr>
+          <p:cNvPr id="31" name="Rechteck 30">
+            <a:extLst>
+              <a:ext uri="{FF2B5EF4-FFF2-40B4-BE49-F238E27FC236}">
+                <a16:creationId xmlns:a16="http://schemas.microsoft.com/office/drawing/2014/main" id="{ED01CE41-2D89-41FF-9721-FB5B35251012}"/>
+              </a:ext>
+            </a:extLst>
+          </p:cNvPr>
+          <p:cNvSpPr/>
+          <p:nvPr/>
+        </p:nvSpPr>
+        <p:spPr>
+          <a:xfrm>
+            <a:off x="47337" y="2398083"/>
+            <a:ext cx="418704" cy="246221"/>
+          </a:xfrm>
+          <a:prstGeom prst="rect">
+            <a:avLst/>
+          </a:prstGeom>
+        </p:spPr>
+        <p:txBody>
+          <a:bodyPr wrap="none">
+            <a:spAutoFit/>
+          </a:bodyPr>
+          <a:lstStyle/>
+          <a:p>
+            <a:pPr algn="ctr"/>
+            <a:r>
+              <a:rPr lang="de-DE" sz="1000" b="1" dirty="0"/>
+              <a:t>Max</a:t>
+            </a:r>
+          </a:p>
+        </p:txBody>
+      </p:sp>
+      <p:sp>
+        <p:nvSpPr>
+          <p:cNvPr id="32" name="Rechteck 31">
+            <a:extLst>
+              <a:ext uri="{FF2B5EF4-FFF2-40B4-BE49-F238E27FC236}">
+                <a16:creationId xmlns:a16="http://schemas.microsoft.com/office/drawing/2014/main" id="{84BB6511-75B5-4D43-853A-1540D0487A01}"/>
+              </a:ext>
+            </a:extLst>
+          </p:cNvPr>
+          <p:cNvSpPr/>
+          <p:nvPr/>
+        </p:nvSpPr>
+        <p:spPr>
+          <a:xfrm>
+            <a:off x="57757" y="3258264"/>
+            <a:ext cx="397866" cy="246221"/>
+          </a:xfrm>
+          <a:prstGeom prst="rect">
+            <a:avLst/>
+          </a:prstGeom>
+        </p:spPr>
+        <p:txBody>
+          <a:bodyPr wrap="none">
+            <a:spAutoFit/>
+          </a:bodyPr>
+          <a:lstStyle/>
+          <a:p>
+            <a:pPr algn="ctr"/>
+            <a:r>
+              <a:rPr lang="de-DE" sz="1000" b="1" dirty="0"/>
+              <a:t>Min</a:t>
+            </a:r>
+          </a:p>
+        </p:txBody>
+      </p:sp>
+      <p:grpSp>
+        <p:nvGrpSpPr>
+          <p:cNvPr id="66" name="Gruppieren 65">
+            <a:extLst>
+              <a:ext uri="{FF2B5EF4-FFF2-40B4-BE49-F238E27FC236}">
+                <a16:creationId xmlns:a16="http://schemas.microsoft.com/office/drawing/2014/main" id="{0E62FA08-E1EC-454B-8C12-E9E5B8A2884E}"/>
+              </a:ext>
+            </a:extLst>
+          </p:cNvPr>
+          <p:cNvGrpSpPr/>
+          <p:nvPr/>
+        </p:nvGrpSpPr>
+        <p:grpSpPr>
+          <a:xfrm>
+            <a:off x="544931" y="2532097"/>
+            <a:ext cx="1571643" cy="851213"/>
+            <a:chOff x="544931" y="2532097"/>
+            <a:chExt cx="1571643" cy="851213"/>
+          </a:xfrm>
+        </p:grpSpPr>
+        <p:cxnSp>
+          <p:nvCxnSpPr>
+            <p:cNvPr id="34" name="Gerader Verbinder 33">
+              <a:extLst>
+                <a:ext uri="{FF2B5EF4-FFF2-40B4-BE49-F238E27FC236}">
+                  <a16:creationId xmlns:a16="http://schemas.microsoft.com/office/drawing/2014/main" id="{8355CD14-E5D7-4CB1-9B3D-4450BDEB5E21}"/>
+                </a:ext>
+              </a:extLst>
+            </p:cNvPr>
+            <p:cNvCxnSpPr>
+              <a:cxnSpLocks/>
+            </p:cNvCxnSpPr>
+            <p:nvPr/>
+          </p:nvCxnSpPr>
+          <p:spPr>
+            <a:xfrm flipV="1">
+              <a:off x="544931" y="3381374"/>
+              <a:ext cx="789994" cy="1"/>
+            </a:xfrm>
+            <a:prstGeom prst="line">
+              <a:avLst/>
+            </a:prstGeom>
+            <a:ln w="25400">
+              <a:solidFill>
+                <a:srgbClr val="C00000">
+                  <a:alpha val="75000"/>
+                </a:srgbClr>
+              </a:solidFill>
+            </a:ln>
+          </p:spPr>
+          <p:style>
+            <a:lnRef idx="1">
+              <a:schemeClr val="accent1"/>
+            </a:lnRef>
+            <a:fillRef idx="0">
+              <a:schemeClr val="accent1"/>
+            </a:fillRef>
+            <a:effectRef idx="0">
+              <a:schemeClr val="accent1"/>
+            </a:effectRef>
+            <a:fontRef idx="minor">
+              <a:schemeClr val="tx1"/>
+            </a:fontRef>
+          </p:style>
+        </p:cxnSp>
+        <p:cxnSp>
+          <p:nvCxnSpPr>
+            <p:cNvPr id="36" name="Gerader Verbinder 35">
+              <a:extLst>
+                <a:ext uri="{FF2B5EF4-FFF2-40B4-BE49-F238E27FC236}">
+                  <a16:creationId xmlns:a16="http://schemas.microsoft.com/office/drawing/2014/main" id="{B882BF72-4683-4338-9216-F60DE7DFED3D}"/>
+                </a:ext>
+              </a:extLst>
+            </p:cNvPr>
+            <p:cNvCxnSpPr>
+              <a:cxnSpLocks/>
+            </p:cNvCxnSpPr>
+            <p:nvPr/>
+          </p:nvCxnSpPr>
+          <p:spPr>
+            <a:xfrm flipV="1">
+              <a:off x="1334925" y="3238838"/>
+              <a:ext cx="117812" cy="144472"/>
+            </a:xfrm>
+            <a:prstGeom prst="line">
+              <a:avLst/>
+            </a:prstGeom>
+            <a:ln w="25400">
+              <a:solidFill>
+                <a:srgbClr val="C00000">
+                  <a:alpha val="75000"/>
+                </a:srgbClr>
+              </a:solidFill>
+            </a:ln>
+          </p:spPr>
+          <p:style>
+            <a:lnRef idx="1">
+              <a:schemeClr val="accent1"/>
+            </a:lnRef>
+            <a:fillRef idx="0">
+              <a:schemeClr val="accent1"/>
+            </a:fillRef>
+            <a:effectRef idx="0">
+              <a:schemeClr val="accent1"/>
+            </a:effectRef>
+            <a:fontRef idx="minor">
+              <a:schemeClr val="tx1"/>
+            </a:fontRef>
+          </p:style>
+        </p:cxnSp>
+        <p:cxnSp>
+          <p:nvCxnSpPr>
+            <p:cNvPr id="39" name="Gerader Verbinder 38">
+              <a:extLst>
+                <a:ext uri="{FF2B5EF4-FFF2-40B4-BE49-F238E27FC236}">
+                  <a16:creationId xmlns:a16="http://schemas.microsoft.com/office/drawing/2014/main" id="{641A49D0-34BF-4783-B0E4-00907D6761CF}"/>
+                </a:ext>
+              </a:extLst>
+            </p:cNvPr>
+            <p:cNvCxnSpPr>
+              <a:cxnSpLocks/>
+            </p:cNvCxnSpPr>
+            <p:nvPr/>
+          </p:nvCxnSpPr>
+          <p:spPr>
+            <a:xfrm flipV="1">
+              <a:off x="1449562" y="2912626"/>
+              <a:ext cx="104601" cy="326473"/>
+            </a:xfrm>
+            <a:prstGeom prst="line">
+              <a:avLst/>
+            </a:prstGeom>
+            <a:ln w="25400">
+              <a:solidFill>
+                <a:srgbClr val="C00000">
+                  <a:alpha val="75000"/>
+                </a:srgbClr>
+              </a:solidFill>
+            </a:ln>
+          </p:spPr>
+          <p:style>
+            <a:lnRef idx="1">
+              <a:schemeClr val="accent1"/>
+            </a:lnRef>
+            <a:fillRef idx="0">
+              <a:schemeClr val="accent1"/>
+            </a:fillRef>
+            <a:effectRef idx="0">
+              <a:schemeClr val="accent1"/>
+            </a:effectRef>
+            <a:fontRef idx="minor">
+              <a:schemeClr val="tx1"/>
+            </a:fontRef>
+          </p:style>
+        </p:cxnSp>
+        <p:cxnSp>
+          <p:nvCxnSpPr>
+            <p:cNvPr id="41" name="Gerader Verbinder 40">
+              <a:extLst>
+                <a:ext uri="{FF2B5EF4-FFF2-40B4-BE49-F238E27FC236}">
+                  <a16:creationId xmlns:a16="http://schemas.microsoft.com/office/drawing/2014/main" id="{1789D57C-1A2B-4E1D-81E0-F1FEB3850F9F}"/>
+                </a:ext>
+              </a:extLst>
+            </p:cNvPr>
+            <p:cNvCxnSpPr>
+              <a:cxnSpLocks/>
+            </p:cNvCxnSpPr>
+            <p:nvPr/>
+          </p:nvCxnSpPr>
+          <p:spPr>
+            <a:xfrm flipV="1">
+              <a:off x="1551587" y="2652569"/>
+              <a:ext cx="253432" cy="261341"/>
+            </a:xfrm>
+            <a:prstGeom prst="line">
+              <a:avLst/>
+            </a:prstGeom>
+            <a:ln w="25400">
+              <a:solidFill>
+                <a:srgbClr val="C00000">
+                  <a:alpha val="75000"/>
+                </a:srgbClr>
+              </a:solidFill>
+            </a:ln>
+          </p:spPr>
+          <p:style>
+            <a:lnRef idx="1">
+              <a:schemeClr val="accent1"/>
+            </a:lnRef>
+            <a:fillRef idx="0">
+              <a:schemeClr val="accent1"/>
+            </a:fillRef>
+            <a:effectRef idx="0">
+              <a:schemeClr val="accent1"/>
+            </a:effectRef>
+            <a:fontRef idx="minor">
+              <a:schemeClr val="tx1"/>
+            </a:fontRef>
+          </p:style>
+        </p:cxnSp>
+        <p:cxnSp>
+          <p:nvCxnSpPr>
+            <p:cNvPr id="43" name="Gerader Verbinder 42">
+              <a:extLst>
+                <a:ext uri="{FF2B5EF4-FFF2-40B4-BE49-F238E27FC236}">
+                  <a16:creationId xmlns:a16="http://schemas.microsoft.com/office/drawing/2014/main" id="{A59E4A7E-A3B2-4742-98C2-653231E52116}"/>
+                </a:ext>
+              </a:extLst>
+            </p:cNvPr>
+            <p:cNvCxnSpPr>
+              <a:cxnSpLocks/>
+            </p:cNvCxnSpPr>
+            <p:nvPr/>
+          </p:nvCxnSpPr>
+          <p:spPr>
+            <a:xfrm flipV="1">
+              <a:off x="1802443" y="2532097"/>
+              <a:ext cx="314131" cy="121113"/>
+            </a:xfrm>
+            <a:prstGeom prst="line">
+              <a:avLst/>
+            </a:prstGeom>
+            <a:ln w="25400">
+              <a:solidFill>
+                <a:srgbClr val="C00000">
+                  <a:alpha val="75000"/>
+                </a:srgbClr>
+              </a:solidFill>
+            </a:ln>
+          </p:spPr>
+          <p:style>
+            <a:lnRef idx="1">
+              <a:schemeClr val="accent1"/>
+            </a:lnRef>
+            <a:fillRef idx="0">
+              <a:schemeClr val="accent1"/>
+            </a:fillRef>
+            <a:effectRef idx="0">
+              <a:schemeClr val="accent1"/>
+            </a:effectRef>
+            <a:fontRef idx="minor">
+              <a:schemeClr val="tx1"/>
+            </a:fontRef>
+          </p:style>
+        </p:cxnSp>
+      </p:grpSp>
+      <p:grpSp>
+        <p:nvGrpSpPr>
+          <p:cNvPr id="65" name="Gruppieren 64">
+            <a:extLst>
+              <a:ext uri="{FF2B5EF4-FFF2-40B4-BE49-F238E27FC236}">
+                <a16:creationId xmlns:a16="http://schemas.microsoft.com/office/drawing/2014/main" id="{E91FA4C0-AEA4-456C-95DB-84988FAAC6CC}"/>
+              </a:ext>
+            </a:extLst>
+          </p:cNvPr>
+          <p:cNvGrpSpPr/>
+          <p:nvPr/>
+        </p:nvGrpSpPr>
+        <p:grpSpPr>
+          <a:xfrm>
+            <a:off x="2116574" y="2532097"/>
+            <a:ext cx="1571643" cy="851213"/>
+            <a:chOff x="2116574" y="2532097"/>
+            <a:chExt cx="1571643" cy="851213"/>
+          </a:xfrm>
+        </p:grpSpPr>
+        <p:cxnSp>
+          <p:nvCxnSpPr>
+            <p:cNvPr id="60" name="Gerader Verbinder 59">
+              <a:extLst>
+                <a:ext uri="{FF2B5EF4-FFF2-40B4-BE49-F238E27FC236}">
+                  <a16:creationId xmlns:a16="http://schemas.microsoft.com/office/drawing/2014/main" id="{64EC05EA-1557-4910-A0B2-1910E869B3F5}"/>
+                </a:ext>
+              </a:extLst>
+            </p:cNvPr>
+            <p:cNvCxnSpPr>
+              <a:cxnSpLocks/>
+            </p:cNvCxnSpPr>
+            <p:nvPr/>
+          </p:nvCxnSpPr>
+          <p:spPr>
+            <a:xfrm flipH="1" flipV="1">
+              <a:off x="2898223" y="3381374"/>
+              <a:ext cx="789994" cy="1"/>
+            </a:xfrm>
+            <a:prstGeom prst="line">
+              <a:avLst/>
+            </a:prstGeom>
+            <a:ln w="25400">
+              <a:solidFill>
+                <a:srgbClr val="C00000">
+                  <a:alpha val="78000"/>
+                </a:srgbClr>
+              </a:solidFill>
+            </a:ln>
+          </p:spPr>
+          <p:style>
+            <a:lnRef idx="1">
+              <a:schemeClr val="accent1"/>
+            </a:lnRef>
+            <a:fillRef idx="0">
+              <a:schemeClr val="accent1"/>
+            </a:fillRef>
+            <a:effectRef idx="0">
+              <a:schemeClr val="accent1"/>
+            </a:effectRef>
+            <a:fontRef idx="minor">
+              <a:schemeClr val="tx1"/>
+            </a:fontRef>
+          </p:style>
+        </p:cxnSp>
+        <p:cxnSp>
+          <p:nvCxnSpPr>
+            <p:cNvPr id="61" name="Gerader Verbinder 60">
+              <a:extLst>
+                <a:ext uri="{FF2B5EF4-FFF2-40B4-BE49-F238E27FC236}">
+                  <a16:creationId xmlns:a16="http://schemas.microsoft.com/office/drawing/2014/main" id="{46DEC3A6-6B50-4A17-874F-44E860A7BDF9}"/>
+                </a:ext>
+              </a:extLst>
+            </p:cNvPr>
+            <p:cNvCxnSpPr>
+              <a:cxnSpLocks/>
+            </p:cNvCxnSpPr>
+            <p:nvPr/>
+          </p:nvCxnSpPr>
+          <p:spPr>
+            <a:xfrm flipH="1" flipV="1">
+              <a:off x="2780411" y="3238838"/>
+              <a:ext cx="117812" cy="144472"/>
+            </a:xfrm>
+            <a:prstGeom prst="line">
+              <a:avLst/>
+            </a:prstGeom>
+            <a:ln w="25400">
+              <a:solidFill>
+                <a:srgbClr val="C00000">
+                  <a:alpha val="78000"/>
+                </a:srgbClr>
+              </a:solidFill>
+            </a:ln>
+          </p:spPr>
+          <p:style>
+            <a:lnRef idx="1">
+              <a:schemeClr val="accent1"/>
+            </a:lnRef>
+            <a:fillRef idx="0">
+              <a:schemeClr val="accent1"/>
+            </a:fillRef>
+            <a:effectRef idx="0">
+              <a:schemeClr val="accent1"/>
+            </a:effectRef>
+            <a:fontRef idx="minor">
+              <a:schemeClr val="tx1"/>
+            </a:fontRef>
+          </p:style>
+        </p:cxnSp>
+        <p:cxnSp>
+          <p:nvCxnSpPr>
+            <p:cNvPr id="62" name="Gerader Verbinder 61">
+              <a:extLst>
+                <a:ext uri="{FF2B5EF4-FFF2-40B4-BE49-F238E27FC236}">
+                  <a16:creationId xmlns:a16="http://schemas.microsoft.com/office/drawing/2014/main" id="{51A6A169-0AA8-4EC7-AFBF-FDE7ED259B84}"/>
+                </a:ext>
+              </a:extLst>
+            </p:cNvPr>
+            <p:cNvCxnSpPr>
+              <a:cxnSpLocks/>
+            </p:cNvCxnSpPr>
+            <p:nvPr/>
+          </p:nvCxnSpPr>
+          <p:spPr>
+            <a:xfrm flipH="1" flipV="1">
+              <a:off x="2678985" y="2912626"/>
+              <a:ext cx="104601" cy="326473"/>
+            </a:xfrm>
+            <a:prstGeom prst="line">
+              <a:avLst/>
+            </a:prstGeom>
+            <a:ln w="25400">
+              <a:solidFill>
+                <a:srgbClr val="C00000">
+                  <a:alpha val="78000"/>
+                </a:srgbClr>
+              </a:solidFill>
+            </a:ln>
+          </p:spPr>
+          <p:style>
+            <a:lnRef idx="1">
+              <a:schemeClr val="accent1"/>
+            </a:lnRef>
+            <a:fillRef idx="0">
+              <a:schemeClr val="accent1"/>
+            </a:fillRef>
+            <a:effectRef idx="0">
+              <a:schemeClr val="accent1"/>
+            </a:effectRef>
+            <a:fontRef idx="minor">
+              <a:schemeClr val="tx1"/>
+            </a:fontRef>
+          </p:style>
+        </p:cxnSp>
+        <p:cxnSp>
+          <p:nvCxnSpPr>
+            <p:cNvPr id="63" name="Gerader Verbinder 62">
+              <a:extLst>
+                <a:ext uri="{FF2B5EF4-FFF2-40B4-BE49-F238E27FC236}">
+                  <a16:creationId xmlns:a16="http://schemas.microsoft.com/office/drawing/2014/main" id="{153357D5-7EBB-4594-9044-E0E8F2B872EA}"/>
+                </a:ext>
+              </a:extLst>
+            </p:cNvPr>
+            <p:cNvCxnSpPr>
+              <a:cxnSpLocks/>
+            </p:cNvCxnSpPr>
+            <p:nvPr/>
+          </p:nvCxnSpPr>
+          <p:spPr>
+            <a:xfrm flipH="1" flipV="1">
+              <a:off x="2428129" y="2652569"/>
+              <a:ext cx="253432" cy="261341"/>
+            </a:xfrm>
+            <a:prstGeom prst="line">
+              <a:avLst/>
+            </a:prstGeom>
+            <a:ln w="25400">
+              <a:solidFill>
+                <a:srgbClr val="C00000">
+                  <a:alpha val="78000"/>
+                </a:srgbClr>
+              </a:solidFill>
+            </a:ln>
+          </p:spPr>
+          <p:style>
+            <a:lnRef idx="1">
+              <a:schemeClr val="accent1"/>
+            </a:lnRef>
+            <a:fillRef idx="0">
+              <a:schemeClr val="accent1"/>
+            </a:fillRef>
+            <a:effectRef idx="0">
+              <a:schemeClr val="accent1"/>
+            </a:effectRef>
+            <a:fontRef idx="minor">
+              <a:schemeClr val="tx1"/>
+            </a:fontRef>
+          </p:style>
+        </p:cxnSp>
+        <p:cxnSp>
+          <p:nvCxnSpPr>
+            <p:cNvPr id="64" name="Gerader Verbinder 63">
+              <a:extLst>
+                <a:ext uri="{FF2B5EF4-FFF2-40B4-BE49-F238E27FC236}">
+                  <a16:creationId xmlns:a16="http://schemas.microsoft.com/office/drawing/2014/main" id="{34EC7AE6-5036-434E-B76F-80B4BE99C654}"/>
+                </a:ext>
+              </a:extLst>
+            </p:cNvPr>
+            <p:cNvCxnSpPr>
+              <a:cxnSpLocks/>
+            </p:cNvCxnSpPr>
+            <p:nvPr/>
+          </p:nvCxnSpPr>
+          <p:spPr>
+            <a:xfrm flipH="1" flipV="1">
+              <a:off x="2116574" y="2532097"/>
+              <a:ext cx="314131" cy="121113"/>
+            </a:xfrm>
+            <a:prstGeom prst="line">
+              <a:avLst/>
+            </a:prstGeom>
+            <a:ln w="25400">
+              <a:solidFill>
+                <a:srgbClr val="C00000">
+                  <a:alpha val="78000"/>
+                </a:srgbClr>
+              </a:solidFill>
+            </a:ln>
+          </p:spPr>
+          <p:style>
+            <a:lnRef idx="1">
+              <a:schemeClr val="accent1"/>
+            </a:lnRef>
+            <a:fillRef idx="0">
+              <a:schemeClr val="accent1"/>
+            </a:fillRef>
+            <a:effectRef idx="0">
+              <a:schemeClr val="accent1"/>
+            </a:effectRef>
+            <a:fontRef idx="minor">
+              <a:schemeClr val="tx1"/>
+            </a:fontRef>
+          </p:style>
+        </p:cxnSp>
+      </p:grpSp>
     </p:spTree>
     <p:extLst>
       <p:ext uri="{BB962C8B-B14F-4D97-AF65-F5344CB8AC3E}">

</xml_diff>